<commit_message>
docs: verify the README from a fresh clone and close the project checklist
A fresh clone followed the README step by step: the regenerated data matched, the committed selection lock verified against the checked-out artifacts, finalize refused to run again, and the suite passed (1267 passed). RUNBOOK gains the measured clone-to-results sequence; the project checklist is ticked with re-checkable evidence. Also removes the two empty placeholder folders left from the retired architecture, which nothing referenced.

Co-Authored-By: Claude Opus 5.5 <noreply@anthropic.com>
</commit_message>
<xml_diff>
--- a/deliverables/slides.pptx
+++ b/deliverables/slides.pptx
@@ -128,14 +128,14 @@
   <p:extLst>
     <p:ext uri="{521415D9-36F7-43E2-AB2F-B90AF26B5E84}">
       <p14:sectionLst xmlns:p14="http://schemas.microsoft.com/office/powerpoint/2010/main">
-        <p14:section name="บทนำ" id="{08ca54fe-bf53-2d4b-bf18-cc7d60f0efab}">
+        <p14:section name="บทนำ" id="{fcd48c5f-3815-301e-9ecf-447fe1a0a4c8}">
           <p14:sldIdLst>
             <p14:sldId id="256"/>
             <p14:sldId id="257"/>
             <p14:sldId id="258"/>
           </p14:sldIdLst>
         </p14:section>
-        <p14:section name="ข้อมูล" id="{ed0990f4-9410-8da3-9eaa-66023f4edcad}">
+        <p14:section name="ข้อมูล" id="{8e1777b7-2d5a-efe6-cce9-951c1b20e664}">
           <p14:sldIdLst>
             <p14:sldId id="259"/>
             <p14:sldId id="260"/>
@@ -145,7 +145,7 @@
             <p14:sldId id="264"/>
           </p14:sldIdLst>
         </p14:section>
-        <p14:section name="โมเดล" id="{8ec60988-27d7-223d-641b-2eb73b169231}">
+        <p14:section name="โมเดล" id="{1942f0d4-0780-2a7b-f40b-ffe53953ffdf}">
           <p14:sldIdLst>
             <p14:sldId id="265"/>
             <p14:sldId id="266"/>
@@ -154,7 +154,7 @@
             <p14:sldId id="269"/>
           </p14:sldIdLst>
         </p14:section>
-        <p14:section name="ผลการทดลอง" id="{307c7c67-816a-1262-9225-ce244de7185b}">
+        <p14:section name="ผลการทดลอง" id="{f902e820-aedd-f503-45f0-98364a061c6b}">
           <p14:sldIdLst>
             <p14:sldId id="270"/>
             <p14:sldId id="271"/>
@@ -163,7 +163,7 @@
             <p14:sldId id="274"/>
           </p14:sldIdLst>
         </p14:section>
-        <p14:section name="อภิปรายและสรุป" id="{31fdc9e1-23b0-bf1f-c2eb-69f940db773c}">
+        <p14:section name="อภิปรายและสรุป" id="{5234a8c3-9907-d25e-0ae1-6e82647dc651}">
           <p14:sldIdLst>
             <p14:sldId id="275"/>
             <p14:sldId id="276"/>
@@ -1368,7 +1368,7 @@
           <a:p>
             <a:r>
               <a:rPr lang="en-US" dirty="0"/>
-              <a:t>เราพิสูจน์ความถูกต้องสามทาง หนึ่ง เทียบคำทำนายกับ library ทีละแถว 14 จาก 19 โมเดลตรงกันทุกแถวหรือถึงทศนิยมสุดท้าย ตัวที่ต่างมีเหตุผลอธิบายได้ เช่นกฎหยุดวนรอบต่างกัน สอง โมเดลทั้ง 38 ชุดบันทึก โหลดกลับ แล้วทำนายได้ค่าเดิม สาม มี test อัตโนมัติกว่า 1,200 ข้อ รวม test ที่กันข้อมูลรั่ว</a:t>
+              <a:t>เราพิสูจน์ความถูกต้องสามทาง หนึ่ง เทียบคำทำนายกับ library ทีละแถว 14 จาก 19 โมเดลตรงกันทุกแถว หรือต่างไม่เกินระดับ 1e-15 ตัวที่ต่างมีเหตุผลอธิบายได้ เช่นกฎหยุดวนรอบต่างกัน สอง โมเดลทั้ง 38 ชุดบันทึก โหลดกลับ แล้วทำนายได้ค่าเดิม สาม มี test อัตโนมัติกว่า 1,200 ข้อ รวม test ที่กันข้อมูลรั่ว</a:t>
             </a:r>
             <a:endParaRPr lang="en-US" dirty="0"/>
           </a:p>
@@ -6889,7 +6889,7 @@
                   <a:schemeClr val="tx2"/>
                 </a:solidFill>
               </a:rPr>
-              <a:t>โมเดลที่คำทำนายตรงกับ scikit-learn / XGBoost ทุกแถว</a:t>
+              <a:t>โมเดลที่ตรงกับ scikit-learn / XGBoost ถึงระดับ 1e-15 หรือตรงทุกแถว</a:t>
             </a:r>
             <a:endParaRPr lang="en-US" sz="1400" dirty="0"/>
           </a:p>
@@ -7081,7 +7081,7 @@
                             <a:schemeClr val="bg1"/>
                           </a:solidFill>
                         </a:rPr>
-                        <a:t>โมเดลที่ไม่ตรงทุกแถว</a:t>
+                        <a:t>อีก 5 โมเดล</a:t>
                       </a:r>
                       <a:endParaRPr lang="en-US" sz="1300" dirty="0"/>
                     </a:p>

</xml_diff>